<commit_message>
Rebuild weekly report around the week's big milestones, tighten roadmap
Slide 1 previously only reflected today's session (CAPEX unit-cost
tweaks, formatting fixes) and buried the actual week's substantive
work. Rebuilt 진행사항 to lead with the real big rocks pulled from
the full week's git history (94 commits before today): building the
entire pricing/BEP engine from the floorplans, acquiring and
cross-checking real SP/FF contracts and proposals, confirming actual
candidate property lease terms, verifying CAPEX line items against
real vendor quotes, and iterating the floorplan/furniture design —
with today's refinements folded in as sub-bullets under each theme.

Slide 2 (roadmap): renamed 부사장 투자승인→내부 투자승인, moved it to
7월 중순 (was unrealistically 4 weeks out at 7월말), shifted every
downstream phase earlier and shortened the longer bars (인테리어
시공 10~11월→9~10월), and dropped the "1~2개월 지연 가능" caveat
since the user already knows.
</commit_message>
<xml_diff>
--- a/프로젝트_SOS_주간보고.pptx
+++ b/프로젝트_SOS_주간보고.pptx
@@ -1680,7 +1680,7 @@
                           <a:ea typeface="Malgun Gothic" pitchFamily="34" charset="-122"/>
                           <a:cs typeface="Malgun Gothic" pitchFamily="34" charset="-120"/>
                         </a:rPr>
-                        <a:t>회원보증금 신규 도입 (SP 실계약 5건 검증)</a:t>
+                        <a:t>SOS 수익성 모델 전체 설계·구축</a:t>
                       </a:r>
                       <a:endParaRPr lang="en-US" sz="1200" dirty="0"/>
                     </a:p>
@@ -1701,7 +1701,7 @@
                           <a:ea typeface="Malgun Gothic" pitchFamily="34" charset="-122"/>
                           <a:cs typeface="Malgun Gothic" pitchFamily="34" charset="-120"/>
                         </a:rPr>
-                        <a:t>부가세포함 표준요금×2개월 공식을 SP 실계약서 5건 대조로 검증</a:t>
+                        <a:t>배치도(룸 배치·문·복도) 기준으로 좌석·룸수·매출이 자동 산출되는 계산 엔진 구축(4개 모델)</a:t>
                       </a:r>
                       <a:endParaRPr lang="en-US" sz="1200" dirty="0"/>
                     </a:p>
@@ -1722,7 +1722,28 @@
                           <a:ea typeface="Malgun Gothic" pitchFamily="34" charset="-122"/>
                           <a:cs typeface="Malgun Gothic" pitchFamily="34" charset="-120"/>
                         </a:rPr>
-                        <a:t>SOS 단기계약 특성 반영: 1주=0 / 1~5개월=1개월치 / 6~11개월=1.5개월치 / 1년이상=2개월치</a:t>
+                        <a:t>가격정책을 "BEP 65% 역산가 + 경쟁사 상한 체크" 방식으로 확정</a:t>
+                      </a:r>
+                      <a:endParaRPr lang="en-US" sz="1200" dirty="0"/>
+                    </a:p>
+                    <a:p>
+                      <a:pPr marL="342900" indent="-342900">
+                        <a:spcAft>
+                          <a:spcPts val="300"/>
+                        </a:spcAft>
+                        <a:buSzPct val="100000"/>
+                        <a:buChar char="●"/>
+                      </a:pPr>
+                      <a:r>
+                        <a:rPr lang="en-US" sz="1150" b="1" dirty="0">
+                          <a:solidFill>
+                            <a:srgbClr val="1F2937"/>
+                          </a:solidFill>
+                          <a:latin typeface="Malgun Gothic" pitchFamily="34" charset="0"/>
+                          <a:ea typeface="Malgun Gothic" pitchFamily="34" charset="-122"/>
+                          <a:cs typeface="Malgun Gothic" pitchFamily="34" charset="-120"/>
+                        </a:rPr>
+                        <a:t>경쟁사 실계약·제안서 자료 확보 및 대조</a:t>
                       </a:r>
                       <a:endParaRPr lang="en-US" sz="1200" dirty="0"/>
                     </a:p>
@@ -1743,7 +1764,28 @@
                           <a:ea typeface="Malgun Gothic" pitchFamily="34" charset="-122"/>
                           <a:cs typeface="Malgun Gothic" pitchFamily="34" charset="-120"/>
                         </a:rPr>
-                        <a:t>초기투자금 조달과는 무관함을 명확화(반환의무 부채로 재정의, 보고서 표현 오류 수정)</a:t>
+                        <a:t>스파크플러스·패스트파이브 실계약서·입주제안서 확보(분당2호점·여의도 등) 및 실거래가·크레딧 조건 검증</a:t>
+                      </a:r>
+                      <a:endParaRPr lang="en-US" sz="1200" dirty="0"/>
+                    </a:p>
+                    <a:p>
+                      <a:pPr lvl="1" marL="685800" indent="-342900">
+                        <a:spcAft>
+                          <a:spcPts val="300"/>
+                        </a:spcAft>
+                        <a:buSzPct val="100000"/>
+                        <a:buChar char="▸"/>
+                      </a:pPr>
+                      <a:r>
+                        <a:rPr lang="en-US" sz="1050" dirty="0">
+                          <a:solidFill>
+                            <a:srgbClr val="1F2937"/>
+                          </a:solidFill>
+                          <a:latin typeface="Malgun Gothic" pitchFamily="34" charset="0"/>
+                          <a:ea typeface="Malgun Gothic" pitchFamily="34" charset="-122"/>
+                          <a:cs typeface="Malgun Gothic" pitchFamily="34" charset="-120"/>
+                        </a:rPr>
+                        <a:t>회원보증금 산정식도 SP 실계약 5건 대조로 검증 후 신규 반영</a:t>
                       </a:r>
                       <a:endParaRPr lang="en-US" sz="1200" dirty="0"/>
                     </a:p>
@@ -1764,7 +1806,7 @@
                           <a:ea typeface="Malgun Gothic" pitchFamily="34" charset="-122"/>
                           <a:cs typeface="Malgun Gothic" pitchFamily="34" charset="-120"/>
                         </a:rPr>
-                        <a:t>CAPEX 단가 실측 재검증 및 전체 재계산</a:t>
+                        <a:t>후보 매물 실측 확정</a:t>
                       </a:r>
                       <a:endParaRPr lang="en-US" sz="1200" dirty="0"/>
                     </a:p>
@@ -1785,7 +1827,28 @@
                           <a:ea typeface="Malgun Gothic" pitchFamily="34" charset="-122"/>
                           <a:cs typeface="Malgun Gothic" pitchFamily="34" charset="-120"/>
                         </a:rPr>
-                        <a:t>전기·통신 7만→4만/평 (네트워크공사·전기 견적서 근거 확인)</a:t>
+                        <a:t>판교(에이치스퀘어 S동 B1)·분당 100/120/150평 매물 임대조건(월세·보증금) 실측 확정</a:t>
+                      </a:r>
+                      <a:endParaRPr lang="en-US" sz="1200" dirty="0"/>
+                    </a:p>
+                    <a:p>
+                      <a:pPr marL="342900" indent="-342900">
+                        <a:spcAft>
+                          <a:spcPts val="300"/>
+                        </a:spcAft>
+                        <a:buSzPct val="100000"/>
+                        <a:buChar char="●"/>
+                      </a:pPr>
+                      <a:r>
+                        <a:rPr lang="en-US" sz="1150" b="1" dirty="0">
+                          <a:solidFill>
+                            <a:srgbClr val="1F2937"/>
+                          </a:solidFill>
+                          <a:latin typeface="Malgun Gothic" pitchFamily="34" charset="0"/>
+                          <a:ea typeface="Malgun Gothic" pitchFamily="34" charset="-122"/>
+                          <a:cs typeface="Malgun Gothic" pitchFamily="34" charset="-120"/>
+                        </a:rPr>
+                        <a:t>CAPEX 항목 실제 견적서 기반 검증</a:t>
                       </a:r>
                       <a:endParaRPr lang="en-US" sz="1200" dirty="0"/>
                     </a:p>
@@ -1806,7 +1869,7 @@
                           <a:ea typeface="Malgun Gothic" pitchFamily="34" charset="-122"/>
                           <a:cs typeface="Malgun Gothic" pitchFamily="34" charset="-120"/>
                         </a:rPr>
-                        <a:t>보안·CCTV·출입통제 200만→86만 (ADT캡스 실견적서 확인)</a:t>
+                        <a:t>소방·냉난방·인테리어·도어락·보안 등 실제 견적서/계약서로 단가 검증</a:t>
                       </a:r>
                       <a:endParaRPr lang="en-US" sz="1200" dirty="0"/>
                     </a:p>
@@ -1827,7 +1890,28 @@
                           <a:ea typeface="Malgun Gothic" pitchFamily="34" charset="-122"/>
                           <a:cs typeface="Malgun Gothic" pitchFamily="34" charset="-120"/>
                         </a:rPr>
-                        <a:t>라운지가구 100만→150만 상향(면적 대비 현실화)</a:t>
+                        <a:t>금주 후반: 전기통신 7→4만/평, 보안 200→86만 추가 실측 보정 및 4개 모델 전체 재계산</a:t>
+                      </a:r>
+                      <a:endParaRPr lang="en-US" sz="1200" dirty="0"/>
+                    </a:p>
+                    <a:p>
+                      <a:pPr marL="342900" indent="-342900">
+                        <a:spcAft>
+                          <a:spcPts val="300"/>
+                        </a:spcAft>
+                        <a:buSzPct val="100000"/>
+                        <a:buChar char="●"/>
+                      </a:pPr>
+                      <a:r>
+                        <a:rPr lang="en-US" sz="1150" b="1" dirty="0">
+                          <a:solidFill>
+                            <a:srgbClr val="1F2937"/>
+                          </a:solidFill>
+                          <a:latin typeface="Malgun Gothic" pitchFamily="34" charset="0"/>
+                          <a:ea typeface="Malgun Gothic" pitchFamily="34" charset="-122"/>
+                          <a:cs typeface="Malgun Gothic" pitchFamily="34" charset="-120"/>
+                        </a:rPr>
+                        <a:t>배치도·가구배치 반복 설계</a:t>
                       </a:r>
                       <a:endParaRPr lang="en-US" sz="1200" dirty="0"/>
                     </a:p>
@@ -1848,7 +1932,7 @@
                           <a:ea typeface="Malgun Gothic" pitchFamily="34" charset="-122"/>
                           <a:cs typeface="Malgun Gothic" pitchFamily="34" charset="-120"/>
                         </a:rPr>
-                        <a:t>4개 모델(100평형·120평·150평·판교) BEP·손익·투자금 전체 재계산</a:t>
+                        <a:t>문 위치·책상 배치·비정형 손실 구간 등 실측 렌더링 검증 반복(책상 1200×700mm 최종 반영)</a:t>
                       </a:r>
                       <a:endParaRPr lang="en-US" sz="1200" dirty="0"/>
                     </a:p>
@@ -1869,7 +1953,7 @@
                           <a:ea typeface="Malgun Gothic" pitchFamily="34" charset="-122"/>
                           <a:cs typeface="Malgun Gothic" pitchFamily="34" charset="-120"/>
                         </a:rPr>
-                        <a:t>보고서 투명성·가독성 개선</a:t>
+                        <a:t>보고서 통합 및 산출물 확장</a:t>
                       </a:r>
                       <a:endParaRPr lang="en-US" sz="1200" dirty="0"/>
                     </a:p>
@@ -1890,7 +1974,7 @@
                           <a:ea typeface="Malgun Gothic" pitchFamily="34" charset="-122"/>
                           <a:cs typeface="Malgun Gothic" pitchFamily="34" charset="-120"/>
                         </a:rPr>
-                        <a:t>월별 손익 흐름(현금흐름 워터폴) 표 신설, 전 항목 계산식 노출</a:t>
+                        <a:t>개별 보고서를 SOS_최종보고서.html 하나로 통합, 현금흐름 워터폴 표 등 투명성 개선</a:t>
                       </a:r>
                       <a:endParaRPr lang="en-US" sz="1200" dirty="0"/>
                     </a:p>
@@ -1911,154 +1995,7 @@
                           <a:ea typeface="Malgun Gothic" pitchFamily="34" charset="-122"/>
                           <a:cs typeface="Malgun Gothic" pitchFamily="34" charset="-120"/>
                         </a:rPr>
-                        <a:t>가구배치도 책상 규격 1200×700mm 실측 반영</a:t>
-                      </a:r>
-                      <a:endParaRPr lang="en-US" sz="1200" dirty="0"/>
-                    </a:p>
-                    <a:p>
-                      <a:pPr lvl="1" marL="685800" indent="-342900">
-                        <a:spcAft>
-                          <a:spcPts val="300"/>
-                        </a:spcAft>
-                        <a:buSzPct val="100000"/>
-                        <a:buChar char="▸"/>
-                      </a:pPr>
-                      <a:r>
-                        <a:rPr lang="en-US" sz="1050" dirty="0">
-                          <a:solidFill>
-                            <a:srgbClr val="1F2937"/>
-                          </a:solidFill>
-                          <a:latin typeface="Malgun Gothic" pitchFamily="34" charset="0"/>
-                          <a:ea typeface="Malgun Gothic" pitchFamily="34" charset="-122"/>
-                          <a:cs typeface="Malgun Gothic" pitchFamily="34" charset="-120"/>
-                        </a:rPr>
-                        <a:t>저근거 섹션(전용평당 손익) 삭제 및 섹션 재정비</a:t>
-                      </a:r>
-                      <a:endParaRPr lang="en-US" sz="1200" dirty="0"/>
-                    </a:p>
-                    <a:p>
-                      <a:pPr marL="342900" indent="-342900">
-                        <a:spcAft>
-                          <a:spcPts val="300"/>
-                        </a:spcAft>
-                        <a:buSzPct val="100000"/>
-                        <a:buChar char="●"/>
-                      </a:pPr>
-                      <a:r>
-                        <a:rPr lang="en-US" sz="1150" b="1" dirty="0">
-                          <a:solidFill>
-                            <a:srgbClr val="1F2937"/>
-                          </a:solidFill>
-                          <a:latin typeface="Malgun Gothic" pitchFamily="34" charset="0"/>
-                          <a:ea typeface="Malgun Gothic" pitchFamily="34" charset="-122"/>
-                          <a:cs typeface="Malgun Gothic" pitchFamily="34" charset="-120"/>
-                        </a:rPr>
-                        <a:t>1~4인실 수요 근거 리서치</a:t>
-                      </a:r>
-                      <a:endParaRPr lang="en-US" sz="1200" dirty="0"/>
-                    </a:p>
-                    <a:p>
-                      <a:pPr lvl="1" marL="685800" indent="-342900">
-                        <a:spcAft>
-                          <a:spcPts val="300"/>
-                        </a:spcAft>
-                        <a:buSzPct val="100000"/>
-                        <a:buChar char="▸"/>
-                      </a:pPr>
-                      <a:r>
-                        <a:rPr lang="en-US" sz="1050" dirty="0">
-                          <a:solidFill>
-                            <a:srgbClr val="1F2937"/>
-                          </a:solidFill>
-                          <a:latin typeface="Malgun Gothic" pitchFamily="34" charset="0"/>
-                          <a:ea typeface="Malgun Gothic" pitchFamily="34" charset="-122"/>
-                          <a:cs typeface="Malgun Gothic" pitchFamily="34" charset="-120"/>
-                        </a:rPr>
-                        <a:t>통계청 사업체 규모 분포, 스타트업 팀 규모 등 정황 데이터 확보</a:t>
-                      </a:r>
-                      <a:endParaRPr lang="en-US" sz="1200" dirty="0"/>
-                    </a:p>
-                    <a:p>
-                      <a:pPr lvl="1" marL="685800" indent="-342900">
-                        <a:spcAft>
-                          <a:spcPts val="300"/>
-                        </a:spcAft>
-                        <a:buSzPct val="100000"/>
-                        <a:buChar char="▸"/>
-                      </a:pPr>
-                      <a:r>
-                        <a:rPr lang="en-US" sz="1050" dirty="0">
-                          <a:solidFill>
-                            <a:srgbClr val="1F2937"/>
-                          </a:solidFill>
-                          <a:latin typeface="Malgun Gothic" pitchFamily="34" charset="0"/>
-                          <a:ea typeface="Malgun Gothic" pitchFamily="34" charset="-122"/>
-                          <a:cs typeface="Malgun Gothic" pitchFamily="34" charset="-120"/>
-                        </a:rPr>
-                        <a:t>SP 분당2호점 실제 제안서 확인 — 경쟁사 1~4인실 공급 부재 확인(추가 검증 필요)</a:t>
-                      </a:r>
-                      <a:endParaRPr lang="en-US" sz="1200" dirty="0"/>
-                    </a:p>
-                    <a:p>
-                      <a:pPr marL="342900" indent="-342900">
-                        <a:spcAft>
-                          <a:spcPts val="300"/>
-                        </a:spcAft>
-                        <a:buSzPct val="100000"/>
-                        <a:buChar char="●"/>
-                      </a:pPr>
-                      <a:r>
-                        <a:rPr lang="en-US" sz="1150" b="1" dirty="0">
-                          <a:solidFill>
-                            <a:srgbClr val="1F2937"/>
-                          </a:solidFill>
-                          <a:latin typeface="Malgun Gothic" pitchFamily="34" charset="0"/>
-                          <a:ea typeface="Malgun Gothic" pitchFamily="34" charset="-122"/>
-                          <a:cs typeface="Malgun Gothic" pitchFamily="34" charset="-120"/>
-                        </a:rPr>
-                        <a:t>산출물 다각화</a:t>
-                      </a:r>
-                      <a:endParaRPr lang="en-US" sz="1200" dirty="0"/>
-                    </a:p>
-                    <a:p>
-                      <a:pPr lvl="1" marL="685800" indent="-342900">
-                        <a:spcAft>
-                          <a:spcPts val="300"/>
-                        </a:spcAft>
-                        <a:buSzPct val="100000"/>
-                        <a:buChar char="▸"/>
-                      </a:pPr>
-                      <a:r>
-                        <a:rPr lang="en-US" sz="1050" dirty="0">
-                          <a:solidFill>
-                            <a:srgbClr val="1F2937"/>
-                          </a:solidFill>
-                          <a:latin typeface="Malgun Gothic" pitchFamily="34" charset="0"/>
-                          <a:ea typeface="Malgun Gothic" pitchFamily="34" charset="-122"/>
-                          <a:cs typeface="Malgun Gothic" pitchFamily="34" charset="-120"/>
-                        </a:rPr>
-                        <a:t>전체 보고서 표 Excel 워크북 추출(20개 시트)</a:t>
-                      </a:r>
-                      <a:endParaRPr lang="en-US" sz="1200" dirty="0"/>
-                    </a:p>
-                    <a:p>
-                      <a:pPr lvl="1" marL="685800" indent="-342900">
-                        <a:spcAft>
-                          <a:spcPts val="300"/>
-                        </a:spcAft>
-                        <a:buSzPct val="100000"/>
-                        <a:buChar char="▸"/>
-                      </a:pPr>
-                      <a:r>
-                        <a:rPr lang="en-US" sz="1050" dirty="0">
-                          <a:solidFill>
-                            <a:srgbClr val="1F2937"/>
-                          </a:solidFill>
-                          <a:latin typeface="Malgun Gothic" pitchFamily="34" charset="0"/>
-                          <a:ea typeface="Malgun Gothic" pitchFamily="34" charset="-122"/>
-                          <a:cs typeface="Malgun Gothic" pitchFamily="34" charset="-120"/>
-                        </a:rPr>
-                        <a:t>워드 사업계획서 작성 — 실투자금 2억 현금흐름 기준 회수기간(3.7년) 중심 설득 논리</a:t>
+                        <a:t>Excel(표 20개 시트)·워드 사업계획서·투자설득 PPT·주간보고 PPT까지 산출물 다각화(금주 후반)</a:t>
                       </a:r>
                       <a:endParaRPr lang="en-US" sz="1200" dirty="0"/>
                     </a:p>
@@ -2194,27 +2131,6 @@
                       <a:endParaRPr lang="en-US" sz="1200" dirty="0"/>
                     </a:p>
                     <a:p>
-                      <a:pPr marL="342900" indent="-342900">
-                        <a:spcAft>
-                          <a:spcPts val="300"/>
-                        </a:spcAft>
-                        <a:buSzPct val="100000"/>
-                        <a:buChar char="●"/>
-                      </a:pPr>
-                      <a:r>
-                        <a:rPr lang="en-US" sz="1150" b="1" dirty="0">
-                          <a:solidFill>
-                            <a:srgbClr val="1F2937"/>
-                          </a:solidFill>
-                          <a:latin typeface="Malgun Gothic" pitchFamily="34" charset="0"/>
-                          <a:ea typeface="Malgun Gothic" pitchFamily="34" charset="-122"/>
-                          <a:cs typeface="Malgun Gothic" pitchFamily="34" charset="-120"/>
-                        </a:rPr>
-                        <a:t>후보 매물 실사</a:t>
-                      </a:r>
-                      <a:endParaRPr lang="en-US" sz="1200" dirty="0"/>
-                    </a:p>
-                    <a:p>
                       <a:pPr lvl="1" marL="685800" indent="-342900">
                         <a:spcAft>
                           <a:spcPts val="300"/>
@@ -2231,28 +2147,7 @@
                           <a:ea typeface="Malgun Gothic" pitchFamily="34" charset="-122"/>
                           <a:cs typeface="Malgun Gothic" pitchFamily="34" charset="-120"/>
                         </a:rPr>
-                        <a:t>근생 용도·전대 허용·권리금 여부 확인</a:t>
-                      </a:r>
-                      <a:endParaRPr lang="en-US" sz="1200" dirty="0"/>
-                    </a:p>
-                    <a:p>
-                      <a:pPr lvl="1" marL="685800" indent="-342900">
-                        <a:spcAft>
-                          <a:spcPts val="300"/>
-                        </a:spcAft>
-                        <a:buSzPct val="100000"/>
-                        <a:buChar char="▸"/>
-                      </a:pPr>
-                      <a:r>
-                        <a:rPr lang="en-US" sz="1050" dirty="0">
-                          <a:solidFill>
-                            <a:srgbClr val="1F2937"/>
-                          </a:solidFill>
-                          <a:latin typeface="Malgun Gothic" pitchFamily="34" charset="0"/>
-                          <a:ea typeface="Malgun Gothic" pitchFamily="34" charset="-122"/>
-                          <a:cs typeface="Malgun Gothic" pitchFamily="34" charset="-120"/>
-                        </a:rPr>
-                        <a:t>소방·공조 가견적 확보(스프링클러 설치대상 여부 포함)</a:t>
+                        <a:t>※ 매물 실사(근생 용도·전대·소방)는 내부 투자승인 이후 착수 예정</a:t>
                       </a:r>
                       <a:endParaRPr lang="en-US" sz="1200" dirty="0"/>
                     </a:p>
@@ -2658,7 +2553,7 @@
         <p:spPr>
           <a:xfrm>
             <a:off x="1737360" y="1554480"/>
-            <a:ext cx="1463040" cy="548640"/>
+            <a:ext cx="822960" cy="548640"/>
           </a:xfrm>
           <a:prstGeom prst="roundRect">
             <a:avLst>
@@ -2680,7 +2575,7 @@
         <p:spPr>
           <a:xfrm>
             <a:off x="1737360" y="1554480"/>
-            <a:ext cx="1463040" cy="548640"/>
+            <a:ext cx="822960" cy="548640"/>
           </a:xfrm>
           <a:prstGeom prst="rect">
             <a:avLst/>
@@ -2704,7 +2599,7 @@
                 <a:ea typeface="Malgun Gothic" pitchFamily="34" charset="-122"/>
                 <a:cs typeface="Malgun Gothic" pitchFamily="34" charset="-120"/>
               </a:rPr>
-              <a:t>모델링·CAPEX검증(7월)</a:t>
+              <a:t>모델링·검증</a:t>
             </a:r>
             <a:endParaRPr lang="en-US" sz="1100" dirty="0"/>
           </a:p>
@@ -2718,7 +2613,7 @@
         </p:nvSpPr>
         <p:spPr>
           <a:xfrm rot="-480000">
-            <a:off x="2697480" y="1298448"/>
+            <a:off x="2057400" y="1298448"/>
             <a:ext cx="640080" cy="320040"/>
           </a:xfrm>
           <a:prstGeom prst="rect">
@@ -2763,8 +2658,8 @@
         </p:nvSpPr>
         <p:spPr>
           <a:xfrm>
-            <a:off x="3291840" y="1554480"/>
-            <a:ext cx="1554480" cy="548640"/>
+            <a:off x="2560320" y="1554480"/>
+            <a:ext cx="1005840" cy="548640"/>
           </a:xfrm>
           <a:prstGeom prst="roundRect">
             <a:avLst>
@@ -2785,8 +2680,8 @@
         </p:nvSpPr>
         <p:spPr>
           <a:xfrm>
-            <a:off x="3291840" y="1554480"/>
-            <a:ext cx="1554480" cy="548640"/>
+            <a:off x="2560320" y="1554480"/>
+            <a:ext cx="1005840" cy="548640"/>
           </a:xfrm>
           <a:prstGeom prst="rect">
             <a:avLst/>
@@ -2810,7 +2705,7 @@
                 <a:ea typeface="Malgun Gothic" pitchFamily="34" charset="-122"/>
                 <a:cs typeface="Malgun Gothic" pitchFamily="34" charset="-120"/>
               </a:rPr>
-              <a:t>부사장 투자승인(7월말)</a:t>
+              <a:t>내부 투자승인(7월 중순)</a:t>
             </a:r>
             <a:endParaRPr lang="en-US" sz="1100" dirty="0"/>
           </a:p>
@@ -2863,8 +2758,8 @@
         </p:nvSpPr>
         <p:spPr>
           <a:xfrm>
-            <a:off x="3108960" y="2423160"/>
-            <a:ext cx="1737360" cy="548640"/>
+            <a:off x="3566160" y="2423160"/>
+            <a:ext cx="1188720" cy="548640"/>
           </a:xfrm>
           <a:prstGeom prst="roundRect">
             <a:avLst>
@@ -2885,8 +2780,8 @@
         </p:nvSpPr>
         <p:spPr>
           <a:xfrm>
-            <a:off x="3108960" y="2423160"/>
-            <a:ext cx="1737360" cy="548640"/>
+            <a:off x="3566160" y="2423160"/>
+            <a:ext cx="1188720" cy="548640"/>
           </a:xfrm>
           <a:prstGeom prst="rect">
             <a:avLst/>
@@ -2910,7 +2805,7 @@
                 <a:ea typeface="Malgun Gothic" pitchFamily="34" charset="-122"/>
                 <a:cs typeface="Malgun Gothic" pitchFamily="34" charset="-120"/>
               </a:rPr>
-              <a:t>실사·정식견적(8월)</a:t>
+              <a:t>실사·정식견적(7월말~8월)</a:t>
             </a:r>
             <a:endParaRPr lang="en-US" sz="1100" dirty="0"/>
           </a:p>
@@ -2924,8 +2819,8 @@
         </p:nvSpPr>
         <p:spPr>
           <a:xfrm>
-            <a:off x="4937760" y="2423160"/>
-            <a:ext cx="1463040" cy="548640"/>
+            <a:off x="4754880" y="2423160"/>
+            <a:ext cx="1005840" cy="548640"/>
           </a:xfrm>
           <a:prstGeom prst="roundRect">
             <a:avLst>
@@ -2946,8 +2841,8 @@
         </p:nvSpPr>
         <p:spPr>
           <a:xfrm>
-            <a:off x="4937760" y="2423160"/>
-            <a:ext cx="1463040" cy="548640"/>
+            <a:off x="4754880" y="2423160"/>
+            <a:ext cx="1005840" cy="548640"/>
           </a:xfrm>
           <a:prstGeom prst="rect">
             <a:avLst/>
@@ -2971,7 +2866,7 @@
                 <a:ea typeface="Malgun Gothic" pitchFamily="34" charset="-122"/>
                 <a:cs typeface="Malgun Gothic" pitchFamily="34" charset="-120"/>
               </a:rPr>
-              <a:t>임대차 계약(9월)</a:t>
+              <a:t>임대차 계약(8월말)</a:t>
             </a:r>
             <a:endParaRPr lang="en-US" sz="1100" dirty="0"/>
           </a:p>
@@ -3024,8 +2919,8 @@
         </p:nvSpPr>
         <p:spPr>
           <a:xfrm>
-            <a:off x="5029200" y="3291840"/>
-            <a:ext cx="2011680" cy="548640"/>
+            <a:off x="5760720" y="3291840"/>
+            <a:ext cx="1463040" cy="548640"/>
           </a:xfrm>
           <a:prstGeom prst="roundRect">
             <a:avLst>
@@ -3046,8 +2941,8 @@
         </p:nvSpPr>
         <p:spPr>
           <a:xfrm>
-            <a:off x="5029200" y="3291840"/>
-            <a:ext cx="2011680" cy="548640"/>
+            <a:off x="5760720" y="3291840"/>
+            <a:ext cx="1463040" cy="548640"/>
           </a:xfrm>
           <a:prstGeom prst="rect">
             <a:avLst/>
@@ -3071,7 +2966,7 @@
                 <a:ea typeface="Malgun Gothic" pitchFamily="34" charset="-122"/>
                 <a:cs typeface="Malgun Gothic" pitchFamily="34" charset="-120"/>
               </a:rPr>
-              <a:t>인테리어 시공(10~11월)</a:t>
+              <a:t>인테리어 시공(9~10월)</a:t>
             </a:r>
             <a:endParaRPr lang="en-US" sz="1100" dirty="0"/>
           </a:p>
@@ -3085,8 +2980,8 @@
         </p:nvSpPr>
         <p:spPr>
           <a:xfrm>
-            <a:off x="7132320" y="3291840"/>
-            <a:ext cx="1463040" cy="548640"/>
+            <a:off x="7223760" y="3291840"/>
+            <a:ext cx="1005840" cy="548640"/>
           </a:xfrm>
           <a:prstGeom prst="roundRect">
             <a:avLst>
@@ -3107,8 +3002,8 @@
         </p:nvSpPr>
         <p:spPr>
           <a:xfrm>
-            <a:off x="7132320" y="3291840"/>
-            <a:ext cx="1463040" cy="548640"/>
+            <a:off x="7223760" y="3291840"/>
+            <a:ext cx="1005840" cy="548640"/>
           </a:xfrm>
           <a:prstGeom prst="rect">
             <a:avLst/>
@@ -3132,7 +3027,7 @@
                 <a:ea typeface="Malgun Gothic" pitchFamily="34" charset="-122"/>
                 <a:cs typeface="Malgun Gothic" pitchFamily="34" charset="-120"/>
               </a:rPr>
-              <a:t>가구·무인시스템(11월)</a:t>
+              <a:t>가구·무인시스템(10월)</a:t>
             </a:r>
             <a:endParaRPr lang="en-US" sz="1100" dirty="0"/>
           </a:p>
@@ -3185,8 +3080,8 @@
         </p:nvSpPr>
         <p:spPr>
           <a:xfrm>
-            <a:off x="8686800" y="4160520"/>
-            <a:ext cx="1463040" cy="548640"/>
+            <a:off x="8229600" y="4160520"/>
+            <a:ext cx="1188720" cy="548640"/>
           </a:xfrm>
           <a:prstGeom prst="roundRect">
             <a:avLst>
@@ -3207,8 +3102,8 @@
         </p:nvSpPr>
         <p:spPr>
           <a:xfrm>
-            <a:off x="8686800" y="4160520"/>
-            <a:ext cx="1463040" cy="548640"/>
+            <a:off x="8229600" y="4160520"/>
+            <a:ext cx="1188720" cy="548640"/>
           </a:xfrm>
           <a:prstGeom prst="rect">
             <a:avLst/>
@@ -3232,7 +3127,7 @@
                 <a:ea typeface="Malgun Gothic" pitchFamily="34" charset="-122"/>
                 <a:cs typeface="Malgun Gothic" pitchFamily="34" charset="-120"/>
               </a:rPr>
-              <a:t>마케팅·회원모집(12월)</a:t>
+              <a:t>마케팅·회원모집(11월)</a:t>
             </a:r>
             <a:endParaRPr lang="en-US" sz="1100" dirty="0"/>
           </a:p>
@@ -3246,8 +3141,8 @@
         </p:nvSpPr>
         <p:spPr>
           <a:xfrm>
-            <a:off x="10241280" y="4160520"/>
-            <a:ext cx="1097280" cy="548640"/>
+            <a:off x="9418320" y="4160520"/>
+            <a:ext cx="1005840" cy="548640"/>
           </a:xfrm>
           <a:prstGeom prst="roundRect">
             <a:avLst>
@@ -3268,8 +3163,8 @@
         </p:nvSpPr>
         <p:spPr>
           <a:xfrm>
-            <a:off x="10241280" y="4160520"/>
-            <a:ext cx="1097280" cy="548640"/>
+            <a:off x="9418320" y="4160520"/>
+            <a:ext cx="1005840" cy="548640"/>
           </a:xfrm>
           <a:prstGeom prst="rect">
             <a:avLst/>
@@ -3293,7 +3188,7 @@
                 <a:ea typeface="Malgun Gothic" pitchFamily="34" charset="-122"/>
                 <a:cs typeface="Malgun Gothic" pitchFamily="34" charset="-120"/>
               </a:rPr>
-              <a:t>오픈(목표)</a:t>
+              <a:t>오픈(목표, 11월말)</a:t>
             </a:r>
             <a:endParaRPr lang="en-US" sz="1100" dirty="0"/>
           </a:p>
@@ -3346,8 +3241,8 @@
         </p:nvSpPr>
         <p:spPr>
           <a:xfrm>
-            <a:off x="10241280" y="5029200"/>
-            <a:ext cx="1645920" cy="548640"/>
+            <a:off x="10424160" y="5029200"/>
+            <a:ext cx="1463040" cy="548640"/>
           </a:xfrm>
           <a:prstGeom prst="roundRect">
             <a:avLst>
@@ -3368,8 +3263,8 @@
         </p:nvSpPr>
         <p:spPr>
           <a:xfrm>
-            <a:off x="10241280" y="5029200"/>
-            <a:ext cx="1645920" cy="548640"/>
+            <a:off x="10424160" y="5029200"/>
+            <a:ext cx="1463040" cy="548640"/>
           </a:xfrm>
           <a:prstGeom prst="rect">
             <a:avLst/>
@@ -3444,45 +3339,6 @@
             <a:prstDash val="dash"/>
           </a:ln>
         </p:spPr>
-      </p:sp>
-      <p:sp>
-        <p:nvSpPr>
-          <p:cNvPr id="34" name="Text 32"/>
-          <p:cNvSpPr/>
-          <p:nvPr/>
-        </p:nvSpPr>
-        <p:spPr>
-          <a:xfrm>
-            <a:off x="274320" y="5943600"/>
-            <a:ext cx="11612880" cy="457200"/>
-          </a:xfrm>
-          <a:prstGeom prst="rect">
-            <a:avLst/>
-          </a:prstGeom>
-          <a:noFill/>
-          <a:ln/>
-        </p:spPr>
-        <p:txBody>
-          <a:bodyPr wrap="square" rtlCol="0" anchor="ctr"/>
-          <a:lstStyle/>
-          <a:p>
-            <a:pPr indent="0" marL="0">
-              <a:buNone/>
-            </a:pPr>
-            <a:r>
-              <a:rPr lang="en-US" sz="1100" i="1" dirty="0">
-                <a:solidFill>
-                  <a:srgbClr val="B42318"/>
-                </a:solidFill>
-                <a:latin typeface="Malgun Gothic" pitchFamily="34" charset="0"/>
-                <a:ea typeface="Malgun Gothic" pitchFamily="34" charset="-122"/>
-                <a:cs typeface="Malgun Gothic" pitchFamily="34" charset="-120"/>
-              </a:rPr>
-              <a:t>※ 12월 오픈은 상반기 매물 확정·계약이 예정대로 진행될 때의 목표치. 매물 실사 결과에 따라 1~2개월 지연 가능.</a:t>
-            </a:r>
-            <a:endParaRPr lang="en-US" sz="1100" dirty="0"/>
-          </a:p>
-        </p:txBody>
       </p:sp>
     </p:spTree>
   </p:cSld>

</xml_diff>

<commit_message>
Add competitor field visits (분당SP·판교FF·여의도SP) to weekly report
These site visits/consultations were the actual source of the real
contract and quote data used throughout the model, but weren't
visible from git history alone. Added as a stats banner box (3곳) and
as explicit sub-bullets under 경쟁사 현장 상담·방문 및 실자료 확보.
</commit_message>
<xml_diff>
--- a/프로젝트_SOS_주간보고.pptx
+++ b/프로젝트_SOS_주간보고.pptx
@@ -1005,7 +1005,7 @@
         <p:spPr>
           <a:xfrm>
             <a:off x="274320" y="502920"/>
-            <a:ext cx="2834640" cy="777240"/>
+            <a:ext cx="2249424" cy="777240"/>
           </a:xfrm>
           <a:prstGeom prst="roundRect">
             <a:avLst>
@@ -1027,7 +1027,7 @@
         <p:spPr>
           <a:xfrm>
             <a:off x="274320" y="530352"/>
-            <a:ext cx="2834640" cy="365760"/>
+            <a:ext cx="2249424" cy="365760"/>
           </a:xfrm>
           <a:prstGeom prst="rect">
             <a:avLst/>
@@ -1043,7 +1043,124 @@
               <a:buNone/>
             </a:pPr>
             <a:r>
-              <a:rPr lang="en-US" sz="1800" b="1" dirty="0">
+              <a:rPr lang="en-US" sz="1700" b="1" dirty="0">
+                <a:solidFill>
+                  <a:srgbClr val="FFFFFF"/>
+                </a:solidFill>
+                <a:latin typeface="Malgun Gothic" pitchFamily="34" charset="0"/>
+                <a:ea typeface="Malgun Gothic" pitchFamily="34" charset="-122"/>
+                <a:cs typeface="Malgun Gothic" pitchFamily="34" charset="-120"/>
+              </a:rPr>
+              <a:t>3곳</a:t>
+            </a:r>
+            <a:endParaRPr lang="en-US" sz="1700" dirty="0"/>
+          </a:p>
+        </p:txBody>
+      </p:sp>
+      <p:sp>
+        <p:nvSpPr>
+          <p:cNvPr id="5" name="Text 3"/>
+          <p:cNvSpPr/>
+          <p:nvPr/>
+        </p:nvSpPr>
+        <p:spPr>
+          <a:xfrm>
+            <a:off x="274320" y="868680"/>
+            <a:ext cx="2249424" cy="384048"/>
+          </a:xfrm>
+          <a:prstGeom prst="rect">
+            <a:avLst/>
+          </a:prstGeom>
+          <a:noFill/>
+          <a:ln/>
+        </p:spPr>
+        <p:txBody>
+          <a:bodyPr wrap="square" rtlCol="0" anchor="ctr"/>
+          <a:lstStyle/>
+          <a:p>
+            <a:pPr algn="ctr" indent="0" marL="0">
+              <a:buNone/>
+            </a:pPr>
+            <a:r>
+              <a:rPr lang="en-US" sz="800" dirty="0">
+                <a:solidFill>
+                  <a:srgbClr val="D9E2F3"/>
+                </a:solidFill>
+                <a:latin typeface="Malgun Gothic" pitchFamily="34" charset="0"/>
+                <a:ea typeface="Malgun Gothic" pitchFamily="34" charset="-122"/>
+                <a:cs typeface="Malgun Gothic" pitchFamily="34" charset="-120"/>
+              </a:rPr>
+              <a:t>경쟁사 현장 방문·상담</a:t>
+            </a:r>
+            <a:endParaRPr lang="en-US" sz="800" dirty="0"/>
+          </a:p>
+          <a:p>
+            <a:pPr algn="ctr" indent="0" marL="0">
+              <a:buNone/>
+            </a:pPr>
+            <a:r>
+              <a:rPr lang="en-US" sz="800" dirty="0">
+                <a:solidFill>
+                  <a:srgbClr val="D9E2F3"/>
+                </a:solidFill>
+                <a:latin typeface="Malgun Gothic" pitchFamily="34" charset="0"/>
+                <a:ea typeface="Malgun Gothic" pitchFamily="34" charset="-122"/>
+                <a:cs typeface="Malgun Gothic" pitchFamily="34" charset="-120"/>
+              </a:rPr>
+              <a:t>(분당SP·판교FF·여의도SP)</a:t>
+            </a:r>
+            <a:endParaRPr lang="en-US" sz="800" dirty="0"/>
+          </a:p>
+        </p:txBody>
+      </p:sp>
+      <p:sp>
+        <p:nvSpPr>
+          <p:cNvPr id="6" name="Shape 4"/>
+          <p:cNvSpPr/>
+          <p:nvPr/>
+        </p:nvSpPr>
+        <p:spPr>
+          <a:xfrm>
+            <a:off x="2615184" y="502920"/>
+            <a:ext cx="2249424" cy="777240"/>
+          </a:xfrm>
+          <a:prstGeom prst="roundRect">
+            <a:avLst>
+              <a:gd name="adj" fmla="val 7059"/>
+            </a:avLst>
+          </a:prstGeom>
+          <a:solidFill>
+            <a:srgbClr val="1F4F99"/>
+          </a:solidFill>
+          <a:ln/>
+        </p:spPr>
+      </p:sp>
+      <p:sp>
+        <p:nvSpPr>
+          <p:cNvPr id="7" name="Text 5"/>
+          <p:cNvSpPr/>
+          <p:nvPr/>
+        </p:nvSpPr>
+        <p:spPr>
+          <a:xfrm>
+            <a:off x="2615184" y="530352"/>
+            <a:ext cx="2249424" cy="365760"/>
+          </a:xfrm>
+          <a:prstGeom prst="rect">
+            <a:avLst/>
+          </a:prstGeom>
+          <a:noFill/>
+          <a:ln/>
+        </p:spPr>
+        <p:txBody>
+          <a:bodyPr wrap="square" rtlCol="0" anchor="ctr"/>
+          <a:lstStyle/>
+          <a:p>
+            <a:pPr algn="ctr" indent="0" marL="0">
+              <a:buNone/>
+            </a:pPr>
+            <a:r>
+              <a:rPr lang="en-US" sz="1700" b="1" dirty="0">
                 <a:solidFill>
                   <a:srgbClr val="FFFFFF"/>
                 </a:solidFill>
@@ -1053,20 +1170,20 @@
               </a:rPr>
               <a:t>5종</a:t>
             </a:r>
-            <a:endParaRPr lang="en-US" sz="1800" dirty="0"/>
-          </a:p>
-        </p:txBody>
-      </p:sp>
-      <p:sp>
-        <p:nvSpPr>
-          <p:cNvPr id="5" name="Text 3"/>
-          <p:cNvSpPr/>
-          <p:nvPr/>
-        </p:nvSpPr>
-        <p:spPr>
-          <a:xfrm>
-            <a:off x="274320" y="868680"/>
-            <a:ext cx="2834640" cy="384048"/>
+            <a:endParaRPr lang="en-US" sz="1700" dirty="0"/>
+          </a:p>
+        </p:txBody>
+      </p:sp>
+      <p:sp>
+        <p:nvSpPr>
+          <p:cNvPr id="8" name="Text 6"/>
+          <p:cNvSpPr/>
+          <p:nvPr/>
+        </p:nvSpPr>
+        <p:spPr>
+          <a:xfrm>
+            <a:off x="2615184" y="868680"/>
+            <a:ext cx="2249424" cy="384048"/>
           </a:xfrm>
           <a:prstGeom prst="rect">
             <a:avLst/>
@@ -1082,7 +1199,7 @@
               <a:buNone/>
             </a:pPr>
             <a:r>
-              <a:rPr lang="en-US" sz="850" dirty="0">
+              <a:rPr lang="en-US" sz="800" dirty="0">
                 <a:solidFill>
                   <a:srgbClr val="D9E2F3"/>
                 </a:solidFill>
@@ -1092,14 +1209,14 @@
               </a:rPr>
               <a:t>문서 산출물</a:t>
             </a:r>
-            <a:endParaRPr lang="en-US" sz="850" dirty="0"/>
+            <a:endParaRPr lang="en-US" sz="800" dirty="0"/>
           </a:p>
           <a:p>
             <a:pPr algn="ctr" indent="0" marL="0">
               <a:buNone/>
             </a:pPr>
             <a:r>
-              <a:rPr lang="en-US" sz="850" dirty="0">
+              <a:rPr lang="en-US" sz="800" dirty="0">
                 <a:solidFill>
                   <a:srgbClr val="D9E2F3"/>
                 </a:solidFill>
@@ -1109,20 +1226,20 @@
               </a:rPr>
               <a:t>(HTML·Excel·Word·PPT×2)</a:t>
             </a:r>
-            <a:endParaRPr lang="en-US" sz="850" dirty="0"/>
-          </a:p>
-        </p:txBody>
-      </p:sp>
-      <p:sp>
-        <p:nvSpPr>
-          <p:cNvPr id="6" name="Shape 4"/>
-          <p:cNvSpPr/>
-          <p:nvPr/>
-        </p:nvSpPr>
-        <p:spPr>
-          <a:xfrm>
-            <a:off x="3200400" y="502920"/>
-            <a:ext cx="2834640" cy="777240"/>
+            <a:endParaRPr lang="en-US" sz="800" dirty="0"/>
+          </a:p>
+        </p:txBody>
+      </p:sp>
+      <p:sp>
+        <p:nvSpPr>
+          <p:cNvPr id="9" name="Shape 7"/>
+          <p:cNvSpPr/>
+          <p:nvPr/>
+        </p:nvSpPr>
+        <p:spPr>
+          <a:xfrm>
+            <a:off x="4956048" y="502920"/>
+            <a:ext cx="2249424" cy="777240"/>
           </a:xfrm>
           <a:prstGeom prst="roundRect">
             <a:avLst>
@@ -1137,14 +1254,14 @@
       </p:sp>
       <p:sp>
         <p:nvSpPr>
-          <p:cNvPr id="7" name="Text 5"/>
-          <p:cNvSpPr/>
-          <p:nvPr/>
-        </p:nvSpPr>
-        <p:spPr>
-          <a:xfrm>
-            <a:off x="3200400" y="530352"/>
-            <a:ext cx="2834640" cy="365760"/>
+          <p:cNvPr id="10" name="Text 8"/>
+          <p:cNvSpPr/>
+          <p:nvPr/>
+        </p:nvSpPr>
+        <p:spPr>
+          <a:xfrm>
+            <a:off x="4956048" y="530352"/>
+            <a:ext cx="2249424" cy="365760"/>
           </a:xfrm>
           <a:prstGeom prst="rect">
             <a:avLst/>
@@ -1160,7 +1277,7 @@
               <a:buNone/>
             </a:pPr>
             <a:r>
-              <a:rPr lang="en-US" sz="1800" b="1" dirty="0">
+              <a:rPr lang="en-US" sz="1700" b="1" dirty="0">
                 <a:solidFill>
                   <a:srgbClr val="FFFFFF"/>
                 </a:solidFill>
@@ -1170,20 +1287,20 @@
               </a:rPr>
               <a:t>20개</a:t>
             </a:r>
-            <a:endParaRPr lang="en-US" sz="1800" dirty="0"/>
-          </a:p>
-        </p:txBody>
-      </p:sp>
-      <p:sp>
-        <p:nvSpPr>
-          <p:cNvPr id="8" name="Text 6"/>
-          <p:cNvSpPr/>
-          <p:nvPr/>
-        </p:nvSpPr>
-        <p:spPr>
-          <a:xfrm>
-            <a:off x="3200400" y="868680"/>
-            <a:ext cx="2834640" cy="384048"/>
+            <a:endParaRPr lang="en-US" sz="1700" dirty="0"/>
+          </a:p>
+        </p:txBody>
+      </p:sp>
+      <p:sp>
+        <p:nvSpPr>
+          <p:cNvPr id="11" name="Text 9"/>
+          <p:cNvSpPr/>
+          <p:nvPr/>
+        </p:nvSpPr>
+        <p:spPr>
+          <a:xfrm>
+            <a:off x="4956048" y="868680"/>
+            <a:ext cx="2249424" cy="384048"/>
           </a:xfrm>
           <a:prstGeom prst="rect">
             <a:avLst/>
@@ -1199,7 +1316,7 @@
               <a:buNone/>
             </a:pPr>
             <a:r>
-              <a:rPr lang="en-US" sz="850" dirty="0">
+              <a:rPr lang="en-US" sz="800" dirty="0">
                 <a:solidFill>
                   <a:srgbClr val="D9E2F3"/>
                 </a:solidFill>
@@ -1209,14 +1326,14 @@
               </a:rPr>
               <a:t>보고서 표·계산식</a:t>
             </a:r>
-            <a:endParaRPr lang="en-US" sz="850" dirty="0"/>
+            <a:endParaRPr lang="en-US" sz="800" dirty="0"/>
           </a:p>
           <a:p>
             <a:pPr algn="ctr" indent="0" marL="0">
               <a:buNone/>
             </a:pPr>
             <a:r>
-              <a:rPr lang="en-US" sz="850" dirty="0">
+              <a:rPr lang="en-US" sz="800" dirty="0">
                 <a:solidFill>
                   <a:srgbClr val="D9E2F3"/>
                 </a:solidFill>
@@ -1226,20 +1343,20 @@
               </a:rPr>
               <a:t>전면 재검증</a:t>
             </a:r>
-            <a:endParaRPr lang="en-US" sz="850" dirty="0"/>
-          </a:p>
-        </p:txBody>
-      </p:sp>
-      <p:sp>
-        <p:nvSpPr>
-          <p:cNvPr id="9" name="Shape 7"/>
-          <p:cNvSpPr/>
-          <p:nvPr/>
-        </p:nvSpPr>
-        <p:spPr>
-          <a:xfrm>
-            <a:off x="6126480" y="502920"/>
-            <a:ext cx="2834640" cy="777240"/>
+            <a:endParaRPr lang="en-US" sz="800" dirty="0"/>
+          </a:p>
+        </p:txBody>
+      </p:sp>
+      <p:sp>
+        <p:nvSpPr>
+          <p:cNvPr id="12" name="Shape 10"/>
+          <p:cNvSpPr/>
+          <p:nvPr/>
+        </p:nvSpPr>
+        <p:spPr>
+          <a:xfrm>
+            <a:off x="7296912" y="502920"/>
+            <a:ext cx="2249424" cy="777240"/>
           </a:xfrm>
           <a:prstGeom prst="roundRect">
             <a:avLst>
@@ -1254,14 +1371,14 @@
       </p:sp>
       <p:sp>
         <p:nvSpPr>
-          <p:cNvPr id="10" name="Text 8"/>
-          <p:cNvSpPr/>
-          <p:nvPr/>
-        </p:nvSpPr>
-        <p:spPr>
-          <a:xfrm>
-            <a:off x="6126480" y="530352"/>
-            <a:ext cx="2834640" cy="365760"/>
+          <p:cNvPr id="13" name="Text 11"/>
+          <p:cNvSpPr/>
+          <p:nvPr/>
+        </p:nvSpPr>
+        <p:spPr>
+          <a:xfrm>
+            <a:off x="7296912" y="530352"/>
+            <a:ext cx="2249424" cy="365760"/>
           </a:xfrm>
           <a:prstGeom prst="rect">
             <a:avLst/>
@@ -1277,7 +1394,7 @@
               <a:buNone/>
             </a:pPr>
             <a:r>
-              <a:rPr lang="en-US" sz="1800" b="1" dirty="0">
+              <a:rPr lang="en-US" sz="1700" b="1" dirty="0">
                 <a:solidFill>
                   <a:srgbClr val="FFFFFF"/>
                 </a:solidFill>
@@ -1287,20 +1404,20 @@
               </a:rPr>
               <a:t>4개</a:t>
             </a:r>
-            <a:endParaRPr lang="en-US" sz="1800" dirty="0"/>
-          </a:p>
-        </p:txBody>
-      </p:sp>
-      <p:sp>
-        <p:nvSpPr>
-          <p:cNvPr id="11" name="Text 9"/>
-          <p:cNvSpPr/>
-          <p:nvPr/>
-        </p:nvSpPr>
-        <p:spPr>
-          <a:xfrm>
-            <a:off x="6126480" y="868680"/>
-            <a:ext cx="2834640" cy="384048"/>
+            <a:endParaRPr lang="en-US" sz="1700" dirty="0"/>
+          </a:p>
+        </p:txBody>
+      </p:sp>
+      <p:sp>
+        <p:nvSpPr>
+          <p:cNvPr id="14" name="Text 12"/>
+          <p:cNvSpPr/>
+          <p:nvPr/>
+        </p:nvSpPr>
+        <p:spPr>
+          <a:xfrm>
+            <a:off x="7296912" y="868680"/>
+            <a:ext cx="2249424" cy="384048"/>
           </a:xfrm>
           <a:prstGeom prst="rect">
             <a:avLst/>
@@ -1316,7 +1433,7 @@
               <a:buNone/>
             </a:pPr>
             <a:r>
-              <a:rPr lang="en-US" sz="850" dirty="0">
+              <a:rPr lang="en-US" sz="800" dirty="0">
                 <a:solidFill>
                   <a:srgbClr val="D9E2F3"/>
                 </a:solidFill>
@@ -1326,14 +1443,14 @@
               </a:rPr>
               <a:t>모델 전체 재계산</a:t>
             </a:r>
-            <a:endParaRPr lang="en-US" sz="850" dirty="0"/>
+            <a:endParaRPr lang="en-US" sz="800" dirty="0"/>
           </a:p>
           <a:p>
             <a:pPr algn="ctr" indent="0" marL="0">
               <a:buNone/>
             </a:pPr>
             <a:r>
-              <a:rPr lang="en-US" sz="850" dirty="0">
+              <a:rPr lang="en-US" sz="800" dirty="0">
                 <a:solidFill>
                   <a:srgbClr val="D9E2F3"/>
                 </a:solidFill>
@@ -1343,20 +1460,20 @@
               </a:rPr>
               <a:t>(100·120·150평·판교)</a:t>
             </a:r>
-            <a:endParaRPr lang="en-US" sz="850" dirty="0"/>
-          </a:p>
-        </p:txBody>
-      </p:sp>
-      <p:sp>
-        <p:nvSpPr>
-          <p:cNvPr id="12" name="Shape 10"/>
-          <p:cNvSpPr/>
-          <p:nvPr/>
-        </p:nvSpPr>
-        <p:spPr>
-          <a:xfrm>
-            <a:off x="9052560" y="502920"/>
-            <a:ext cx="2834640" cy="777240"/>
+            <a:endParaRPr lang="en-US" sz="800" dirty="0"/>
+          </a:p>
+        </p:txBody>
+      </p:sp>
+      <p:sp>
+        <p:nvSpPr>
+          <p:cNvPr id="15" name="Shape 13"/>
+          <p:cNvSpPr/>
+          <p:nvPr/>
+        </p:nvSpPr>
+        <p:spPr>
+          <a:xfrm>
+            <a:off x="9637776" y="502920"/>
+            <a:ext cx="2249424" cy="777240"/>
           </a:xfrm>
           <a:prstGeom prst="roundRect">
             <a:avLst>
@@ -1371,14 +1488,14 @@
       </p:sp>
       <p:sp>
         <p:nvSpPr>
-          <p:cNvPr id="13" name="Text 11"/>
-          <p:cNvSpPr/>
-          <p:nvPr/>
-        </p:nvSpPr>
-        <p:spPr>
-          <a:xfrm>
-            <a:off x="9052560" y="530352"/>
-            <a:ext cx="2834640" cy="365760"/>
+          <p:cNvPr id="16" name="Text 14"/>
+          <p:cNvSpPr/>
+          <p:nvPr/>
+        </p:nvSpPr>
+        <p:spPr>
+          <a:xfrm>
+            <a:off x="9637776" y="530352"/>
+            <a:ext cx="2249424" cy="365760"/>
           </a:xfrm>
           <a:prstGeom prst="rect">
             <a:avLst/>
@@ -1394,7 +1511,7 @@
               <a:buNone/>
             </a:pPr>
             <a:r>
-              <a:rPr lang="en-US" sz="1800" b="1" dirty="0">
+              <a:rPr lang="en-US" sz="1700" b="1" dirty="0">
                 <a:solidFill>
                   <a:srgbClr val="FFFFFF"/>
                 </a:solidFill>
@@ -1404,20 +1521,20 @@
               </a:rPr>
               <a:t>3건</a:t>
             </a:r>
-            <a:endParaRPr lang="en-US" sz="1800" dirty="0"/>
-          </a:p>
-        </p:txBody>
-      </p:sp>
-      <p:sp>
-        <p:nvSpPr>
-          <p:cNvPr id="14" name="Text 12"/>
-          <p:cNvSpPr/>
-          <p:nvPr/>
-        </p:nvSpPr>
-        <p:spPr>
-          <a:xfrm>
-            <a:off x="9052560" y="868680"/>
-            <a:ext cx="2834640" cy="384048"/>
+            <a:endParaRPr lang="en-US" sz="1700" dirty="0"/>
+          </a:p>
+        </p:txBody>
+      </p:sp>
+      <p:sp>
+        <p:nvSpPr>
+          <p:cNvPr id="17" name="Text 15"/>
+          <p:cNvSpPr/>
+          <p:nvPr/>
+        </p:nvSpPr>
+        <p:spPr>
+          <a:xfrm>
+            <a:off x="9637776" y="868680"/>
+            <a:ext cx="2249424" cy="384048"/>
           </a:xfrm>
           <a:prstGeom prst="rect">
             <a:avLst/>
@@ -1433,7 +1550,7 @@
               <a:buNone/>
             </a:pPr>
             <a:r>
-              <a:rPr lang="en-US" sz="850" dirty="0">
+              <a:rPr lang="en-US" sz="800" dirty="0">
                 <a:solidFill>
                   <a:srgbClr val="D9E2F3"/>
                 </a:solidFill>
@@ -1443,14 +1560,14 @@
               </a:rPr>
               <a:t>실측 견적서 확보</a:t>
             </a:r>
-            <a:endParaRPr lang="en-US" sz="850" dirty="0"/>
+            <a:endParaRPr lang="en-US" sz="800" dirty="0"/>
           </a:p>
           <a:p>
             <a:pPr algn="ctr" indent="0" marL="0">
               <a:buNone/>
             </a:pPr>
             <a:r>
-              <a:rPr lang="en-US" sz="850" dirty="0">
+              <a:rPr lang="en-US" sz="800" dirty="0">
                 <a:solidFill>
                   <a:srgbClr val="D9E2F3"/>
                 </a:solidFill>
@@ -1460,7 +1577,7 @@
               </a:rPr>
               <a:t>(전기·냉난방·소방)</a:t>
             </a:r>
-            <a:endParaRPr lang="en-US" sz="850" dirty="0"/>
+            <a:endParaRPr lang="en-US" sz="800" dirty="0"/>
           </a:p>
         </p:txBody>
       </p:sp>
@@ -1743,7 +1860,7 @@
                           <a:ea typeface="Malgun Gothic" pitchFamily="34" charset="-122"/>
                           <a:cs typeface="Malgun Gothic" pitchFamily="34" charset="-120"/>
                         </a:rPr>
-                        <a:t>경쟁사 실계약·제안서 자료 확보 및 대조</a:t>
+                        <a:t>경쟁사 현장 상담·방문 및 실자료 확보</a:t>
                       </a:r>
                       <a:endParaRPr lang="en-US" sz="1200" dirty="0"/>
                     </a:p>
@@ -1764,7 +1881,49 @@
                           <a:ea typeface="Malgun Gothic" pitchFamily="34" charset="-122"/>
                           <a:cs typeface="Malgun Gothic" pitchFamily="34" charset="-120"/>
                         </a:rPr>
-                        <a:t>스파크플러스·패스트파이브 실계약서·입주제안서 확보(분당2호점·여의도 등) 및 실거래가·크레딧 조건 검증</a:t>
+                        <a:t>분당 스파크플러스, 판교 패스트파이브 상담 및 견적 확인</a:t>
+                      </a:r>
+                      <a:endParaRPr lang="en-US" sz="1200" dirty="0"/>
+                    </a:p>
+                    <a:p>
+                      <a:pPr lvl="1" marL="685800" indent="-342900">
+                        <a:spcAft>
+                          <a:spcPts val="300"/>
+                        </a:spcAft>
+                        <a:buSzPct val="100000"/>
+                        <a:buChar char="▸"/>
+                      </a:pPr>
+                      <a:r>
+                        <a:rPr lang="en-US" sz="1050" dirty="0">
+                          <a:solidFill>
+                            <a:srgbClr val="1F2937"/>
+                          </a:solidFill>
+                          <a:latin typeface="Malgun Gothic" pitchFamily="34" charset="0"/>
+                          <a:ea typeface="Malgun Gothic" pitchFamily="34" charset="-122"/>
+                          <a:cs typeface="Malgun Gothic" pitchFamily="34" charset="-120"/>
+                        </a:rPr>
+                        <a:t>여의도 스파크플러스 현장 방문 및 수치·견적 확인</a:t>
+                      </a:r>
+                      <a:endParaRPr lang="en-US" sz="1200" dirty="0"/>
+                    </a:p>
+                    <a:p>
+                      <a:pPr lvl="1" marL="685800" indent="-342900">
+                        <a:spcAft>
+                          <a:spcPts val="300"/>
+                        </a:spcAft>
+                        <a:buSzPct val="100000"/>
+                        <a:buChar char="▸"/>
+                      </a:pPr>
+                      <a:r>
+                        <a:rPr lang="en-US" sz="1050" dirty="0">
+                          <a:solidFill>
+                            <a:srgbClr val="1F2937"/>
+                          </a:solidFill>
+                          <a:latin typeface="Malgun Gothic" pitchFamily="34" charset="0"/>
+                          <a:ea typeface="Malgun Gothic" pitchFamily="34" charset="-122"/>
+                          <a:cs typeface="Malgun Gothic" pitchFamily="34" charset="-120"/>
+                        </a:rPr>
+                        <a:t>확보한 실계약서·입주제안서로 실거래가·크레딧 조건 대조 검증(분당2호점·여의도 등)</a:t>
                       </a:r>
                       <a:endParaRPr lang="en-US" sz="1200" dirty="0"/>
                     </a:p>

</xml_diff>

<commit_message>
Add 마케팅 계획·실무 논의 phase to roadmap between investment approval and property contract
사업성 검증·투자승인 stays high-level only (no marketing detail there
per direction); the detailed marketing planning and working-level
discussions now get their own lane, running in parallel with 매물
확보·계약 (7월말~8월) rather than being squeezed into the approval
phase.
</commit_message>
<xml_diff>
--- a/프로젝트_SOS_주간보고.pptx
+++ b/프로젝트_SOS_주간보고.pptx
@@ -2903,7 +2903,7 @@
                 <a:ea typeface="Malgun Gothic" pitchFamily="34" charset="-122"/>
                 <a:cs typeface="Malgun Gothic" pitchFamily="34" charset="-120"/>
               </a:rPr>
-              <a:t>매물 확보・계약</a:t>
+              <a:t>마케팅 계획・실무 논의</a:t>
             </a:r>
             <a:endParaRPr lang="en-US" sz="1150" dirty="0"/>
           </a:p>
@@ -2918,7 +2918,7 @@
         <p:spPr>
           <a:xfrm>
             <a:off x="3566160" y="2423160"/>
-            <a:ext cx="1188720" cy="548640"/>
+            <a:ext cx="2194560" cy="548640"/>
           </a:xfrm>
           <a:prstGeom prst="roundRect">
             <a:avLst>
@@ -2926,6 +2926,106 @@
             </a:avLst>
           </a:prstGeom>
           <a:solidFill>
+            <a:srgbClr val="5B7FBF"/>
+          </a:solidFill>
+          <a:ln/>
+        </p:spPr>
+      </p:sp>
+      <p:sp>
+        <p:nvSpPr>
+          <p:cNvPr id="16" name="Text 14"/>
+          <p:cNvSpPr/>
+          <p:nvPr/>
+        </p:nvSpPr>
+        <p:spPr>
+          <a:xfrm>
+            <a:off x="3566160" y="2423160"/>
+            <a:ext cx="2194560" cy="548640"/>
+          </a:xfrm>
+          <a:prstGeom prst="rect">
+            <a:avLst/>
+          </a:prstGeom>
+          <a:noFill/>
+          <a:ln/>
+        </p:spPr>
+        <p:txBody>
+          <a:bodyPr wrap="square" rtlCol="0" anchor="ctr"/>
+          <a:lstStyle/>
+          <a:p>
+            <a:pPr algn="ctr" indent="0" marL="0">
+              <a:buNone/>
+            </a:pPr>
+            <a:r>
+              <a:rPr lang="en-US" sz="1100" b="1" dirty="0">
+                <a:solidFill>
+                  <a:srgbClr val="FFFFFF"/>
+                </a:solidFill>
+                <a:latin typeface="Malgun Gothic" pitchFamily="34" charset="0"/>
+                <a:ea typeface="Malgun Gothic" pitchFamily="34" charset="-122"/>
+                <a:cs typeface="Malgun Gothic" pitchFamily="34" charset="-120"/>
+              </a:rPr>
+              <a:t>마케팅 계획 구체화·실무 협의(7월말~8월)</a:t>
+            </a:r>
+            <a:endParaRPr lang="en-US" sz="1100" dirty="0"/>
+          </a:p>
+        </p:txBody>
+      </p:sp>
+      <p:sp>
+        <p:nvSpPr>
+          <p:cNvPr id="17" name="Text 15"/>
+          <p:cNvSpPr/>
+          <p:nvPr/>
+        </p:nvSpPr>
+        <p:spPr>
+          <a:xfrm>
+            <a:off x="274320" y="3291840"/>
+            <a:ext cx="1371600" cy="548640"/>
+          </a:xfrm>
+          <a:prstGeom prst="rect">
+            <a:avLst/>
+          </a:prstGeom>
+          <a:noFill/>
+          <a:ln/>
+        </p:spPr>
+        <p:txBody>
+          <a:bodyPr wrap="square" rtlCol="0" anchor="ctr"/>
+          <a:lstStyle/>
+          <a:p>
+            <a:pPr indent="0" marL="0">
+              <a:buNone/>
+            </a:pPr>
+            <a:r>
+              <a:rPr lang="en-US" sz="1150" b="1" dirty="0">
+                <a:solidFill>
+                  <a:srgbClr val="0F1E3D"/>
+                </a:solidFill>
+                <a:latin typeface="Malgun Gothic" pitchFamily="34" charset="0"/>
+                <a:ea typeface="Malgun Gothic" pitchFamily="34" charset="-122"/>
+                <a:cs typeface="Malgun Gothic" pitchFamily="34" charset="-120"/>
+              </a:rPr>
+              <a:t>매물 확보・계약</a:t>
+            </a:r>
+            <a:endParaRPr lang="en-US" sz="1150" dirty="0"/>
+          </a:p>
+        </p:txBody>
+      </p:sp>
+      <p:sp>
+        <p:nvSpPr>
+          <p:cNvPr id="18" name="Shape 16"/>
+          <p:cNvSpPr/>
+          <p:nvPr/>
+        </p:nvSpPr>
+        <p:spPr>
+          <a:xfrm>
+            <a:off x="3566160" y="3291840"/>
+            <a:ext cx="1188720" cy="548640"/>
+          </a:xfrm>
+          <a:prstGeom prst="roundRect">
+            <a:avLst>
+              <a:gd name="adj" fmla="val 10000"/>
+            </a:avLst>
+          </a:prstGeom>
+          <a:solidFill>
             <a:srgbClr val="2E5FA8"/>
           </a:solidFill>
           <a:ln/>
@@ -2933,13 +3033,13 @@
       </p:sp>
       <p:sp>
         <p:nvSpPr>
-          <p:cNvPr id="16" name="Text 14"/>
-          <p:cNvSpPr/>
-          <p:nvPr/>
-        </p:nvSpPr>
-        <p:spPr>
-          <a:xfrm>
-            <a:off x="3566160" y="2423160"/>
+          <p:cNvPr id="19" name="Text 17"/>
+          <p:cNvSpPr/>
+          <p:nvPr/>
+        </p:nvSpPr>
+        <p:spPr>
+          <a:xfrm>
+            <a:off x="3566160" y="3291840"/>
             <a:ext cx="1188720" cy="548640"/>
           </a:xfrm>
           <a:prstGeom prst="rect">
@@ -2972,13 +3072,13 @@
       </p:sp>
       <p:sp>
         <p:nvSpPr>
-          <p:cNvPr id="17" name="Shape 15"/>
-          <p:cNvSpPr/>
-          <p:nvPr/>
-        </p:nvSpPr>
-        <p:spPr>
-          <a:xfrm>
-            <a:off x="4754880" y="2423160"/>
+          <p:cNvPr id="20" name="Shape 18"/>
+          <p:cNvSpPr/>
+          <p:nvPr/>
+        </p:nvSpPr>
+        <p:spPr>
+          <a:xfrm>
+            <a:off x="4754880" y="3291840"/>
             <a:ext cx="1005840" cy="548640"/>
           </a:xfrm>
           <a:prstGeom prst="roundRect">
@@ -2994,13 +3094,13 @@
       </p:sp>
       <p:sp>
         <p:nvSpPr>
-          <p:cNvPr id="18" name="Text 16"/>
-          <p:cNvSpPr/>
-          <p:nvPr/>
-        </p:nvSpPr>
-        <p:spPr>
-          <a:xfrm>
-            <a:off x="4754880" y="2423160"/>
+          <p:cNvPr id="21" name="Text 19"/>
+          <p:cNvSpPr/>
+          <p:nvPr/>
+        </p:nvSpPr>
+        <p:spPr>
+          <a:xfrm>
+            <a:off x="4754880" y="3291840"/>
             <a:ext cx="1005840" cy="548640"/>
           </a:xfrm>
           <a:prstGeom prst="rect">
@@ -3033,13 +3133,13 @@
       </p:sp>
       <p:sp>
         <p:nvSpPr>
-          <p:cNvPr id="19" name="Text 17"/>
-          <p:cNvSpPr/>
-          <p:nvPr/>
-        </p:nvSpPr>
-        <p:spPr>
-          <a:xfrm>
-            <a:off x="274320" y="3291840"/>
+          <p:cNvPr id="22" name="Text 20"/>
+          <p:cNvSpPr/>
+          <p:nvPr/>
+        </p:nvSpPr>
+        <p:spPr>
+          <a:xfrm>
+            <a:off x="274320" y="4160520"/>
             <a:ext cx="1371600" cy="548640"/>
           </a:xfrm>
           <a:prstGeom prst="rect">
@@ -3072,13 +3172,13 @@
       </p:sp>
       <p:sp>
         <p:nvSpPr>
-          <p:cNvPr id="20" name="Shape 18"/>
-          <p:cNvSpPr/>
-          <p:nvPr/>
-        </p:nvSpPr>
-        <p:spPr>
-          <a:xfrm>
-            <a:off x="5760720" y="3291840"/>
+          <p:cNvPr id="23" name="Shape 21"/>
+          <p:cNvSpPr/>
+          <p:nvPr/>
+        </p:nvSpPr>
+        <p:spPr>
+          <a:xfrm>
+            <a:off x="5760720" y="4160520"/>
             <a:ext cx="1463040" cy="548640"/>
           </a:xfrm>
           <a:prstGeom prst="roundRect">
@@ -3094,13 +3194,13 @@
       </p:sp>
       <p:sp>
         <p:nvSpPr>
-          <p:cNvPr id="21" name="Text 19"/>
-          <p:cNvSpPr/>
-          <p:nvPr/>
-        </p:nvSpPr>
-        <p:spPr>
-          <a:xfrm>
-            <a:off x="5760720" y="3291840"/>
+          <p:cNvPr id="24" name="Text 22"/>
+          <p:cNvSpPr/>
+          <p:nvPr/>
+        </p:nvSpPr>
+        <p:spPr>
+          <a:xfrm>
+            <a:off x="5760720" y="4160520"/>
             <a:ext cx="1463040" cy="548640"/>
           </a:xfrm>
           <a:prstGeom prst="rect">
@@ -3133,13 +3233,13 @@
       </p:sp>
       <p:sp>
         <p:nvSpPr>
-          <p:cNvPr id="22" name="Shape 20"/>
-          <p:cNvSpPr/>
-          <p:nvPr/>
-        </p:nvSpPr>
-        <p:spPr>
-          <a:xfrm>
-            <a:off x="7223760" y="3291840"/>
+          <p:cNvPr id="25" name="Shape 23"/>
+          <p:cNvSpPr/>
+          <p:nvPr/>
+        </p:nvSpPr>
+        <p:spPr>
+          <a:xfrm>
+            <a:off x="7223760" y="4160520"/>
             <a:ext cx="1005840" cy="548640"/>
           </a:xfrm>
           <a:prstGeom prst="roundRect">
@@ -3155,13 +3255,13 @@
       </p:sp>
       <p:sp>
         <p:nvSpPr>
-          <p:cNvPr id="23" name="Text 21"/>
-          <p:cNvSpPr/>
-          <p:nvPr/>
-        </p:nvSpPr>
-        <p:spPr>
-          <a:xfrm>
-            <a:off x="7223760" y="3291840"/>
+          <p:cNvPr id="26" name="Text 24"/>
+          <p:cNvSpPr/>
+          <p:nvPr/>
+        </p:nvSpPr>
+        <p:spPr>
+          <a:xfrm>
+            <a:off x="7223760" y="4160520"/>
             <a:ext cx="1005840" cy="548640"/>
           </a:xfrm>
           <a:prstGeom prst="rect">
@@ -3194,13 +3294,13 @@
       </p:sp>
       <p:sp>
         <p:nvSpPr>
-          <p:cNvPr id="24" name="Text 22"/>
-          <p:cNvSpPr/>
-          <p:nvPr/>
-        </p:nvSpPr>
-        <p:spPr>
-          <a:xfrm>
-            <a:off x="274320" y="4160520"/>
+          <p:cNvPr id="27" name="Text 25"/>
+          <p:cNvSpPr/>
+          <p:nvPr/>
+        </p:nvSpPr>
+        <p:spPr>
+          <a:xfrm>
+            <a:off x="274320" y="5029200"/>
             <a:ext cx="1371600" cy="548640"/>
           </a:xfrm>
           <a:prstGeom prst="rect">
@@ -3233,13 +3333,13 @@
       </p:sp>
       <p:sp>
         <p:nvSpPr>
-          <p:cNvPr id="25" name="Shape 23"/>
-          <p:cNvSpPr/>
-          <p:nvPr/>
-        </p:nvSpPr>
-        <p:spPr>
-          <a:xfrm>
-            <a:off x="8229600" y="4160520"/>
+          <p:cNvPr id="28" name="Shape 26"/>
+          <p:cNvSpPr/>
+          <p:nvPr/>
+        </p:nvSpPr>
+        <p:spPr>
+          <a:xfrm>
+            <a:off x="8229600" y="5029200"/>
             <a:ext cx="1188720" cy="548640"/>
           </a:xfrm>
           <a:prstGeom prst="roundRect">
@@ -3255,13 +3355,13 @@
       </p:sp>
       <p:sp>
         <p:nvSpPr>
-          <p:cNvPr id="26" name="Text 24"/>
-          <p:cNvSpPr/>
-          <p:nvPr/>
-        </p:nvSpPr>
-        <p:spPr>
-          <a:xfrm>
-            <a:off x="8229600" y="4160520"/>
+          <p:cNvPr id="29" name="Text 27"/>
+          <p:cNvSpPr/>
+          <p:nvPr/>
+        </p:nvSpPr>
+        <p:spPr>
+          <a:xfrm>
+            <a:off x="8229600" y="5029200"/>
             <a:ext cx="1188720" cy="548640"/>
           </a:xfrm>
           <a:prstGeom prst="rect">
@@ -3294,13 +3394,13 @@
       </p:sp>
       <p:sp>
         <p:nvSpPr>
-          <p:cNvPr id="27" name="Shape 25"/>
-          <p:cNvSpPr/>
-          <p:nvPr/>
-        </p:nvSpPr>
-        <p:spPr>
-          <a:xfrm>
-            <a:off x="9418320" y="4160520"/>
+          <p:cNvPr id="30" name="Shape 28"/>
+          <p:cNvSpPr/>
+          <p:nvPr/>
+        </p:nvSpPr>
+        <p:spPr>
+          <a:xfrm>
+            <a:off x="9418320" y="5029200"/>
             <a:ext cx="1005840" cy="548640"/>
           </a:xfrm>
           <a:prstGeom prst="roundRect">
@@ -3316,13 +3416,13 @@
       </p:sp>
       <p:sp>
         <p:nvSpPr>
-          <p:cNvPr id="28" name="Text 26"/>
-          <p:cNvSpPr/>
-          <p:nvPr/>
-        </p:nvSpPr>
-        <p:spPr>
-          <a:xfrm>
-            <a:off x="9418320" y="4160520"/>
+          <p:cNvPr id="31" name="Text 29"/>
+          <p:cNvSpPr/>
+          <p:nvPr/>
+        </p:nvSpPr>
+        <p:spPr>
+          <a:xfrm>
+            <a:off x="9418320" y="5029200"/>
             <a:ext cx="1005840" cy="548640"/>
           </a:xfrm>
           <a:prstGeom prst="rect">
@@ -3355,13 +3455,13 @@
       </p:sp>
       <p:sp>
         <p:nvSpPr>
-          <p:cNvPr id="29" name="Text 27"/>
-          <p:cNvSpPr/>
-          <p:nvPr/>
-        </p:nvSpPr>
-        <p:spPr>
-          <a:xfrm>
-            <a:off x="274320" y="5029200"/>
+          <p:cNvPr id="32" name="Text 30"/>
+          <p:cNvSpPr/>
+          <p:nvPr/>
+        </p:nvSpPr>
+        <p:spPr>
+          <a:xfrm>
+            <a:off x="274320" y="5897880"/>
             <a:ext cx="1371600" cy="548640"/>
           </a:xfrm>
           <a:prstGeom prst="rect">
@@ -3394,13 +3494,13 @@
       </p:sp>
       <p:sp>
         <p:nvSpPr>
-          <p:cNvPr id="30" name="Shape 28"/>
-          <p:cNvSpPr/>
-          <p:nvPr/>
-        </p:nvSpPr>
-        <p:spPr>
-          <a:xfrm>
-            <a:off x="10424160" y="5029200"/>
+          <p:cNvPr id="33" name="Shape 31"/>
+          <p:cNvSpPr/>
+          <p:nvPr/>
+        </p:nvSpPr>
+        <p:spPr>
+          <a:xfrm>
+            <a:off x="10424160" y="5897880"/>
             <a:ext cx="1463040" cy="548640"/>
           </a:xfrm>
           <a:prstGeom prst="roundRect">
@@ -3416,13 +3516,13 @@
       </p:sp>
       <p:sp>
         <p:nvSpPr>
-          <p:cNvPr id="31" name="Text 29"/>
-          <p:cNvSpPr/>
-          <p:nvPr/>
-        </p:nvSpPr>
-        <p:spPr>
-          <a:xfrm>
-            <a:off x="10424160" y="5029200"/>
+          <p:cNvPr id="34" name="Text 32"/>
+          <p:cNvSpPr/>
+          <p:nvPr/>
+        </p:nvSpPr>
+        <p:spPr>
+          <a:xfrm>
+            <a:off x="10424160" y="5897880"/>
             <a:ext cx="1463040" cy="548640"/>
           </a:xfrm>
           <a:prstGeom prst="rect">
@@ -3455,14 +3555,14 @@
       </p:sp>
       <p:sp>
         <p:nvSpPr>
-          <p:cNvPr id="32" name="Shape 30"/>
+          <p:cNvPr id="35" name="Shape 33"/>
           <p:cNvSpPr/>
           <p:nvPr/>
         </p:nvSpPr>
         <p:spPr>
           <a:xfrm>
             <a:off x="5029200" y="1417320"/>
-            <a:ext cx="0" cy="4206240"/>
+            <a:ext cx="0" cy="5074920"/>
           </a:xfrm>
           <a:prstGeom prst="line">
             <a:avLst/>
@@ -3478,14 +3578,14 @@
       </p:sp>
       <p:sp>
         <p:nvSpPr>
-          <p:cNvPr id="33" name="Shape 31"/>
+          <p:cNvPr id="36" name="Shape 34"/>
           <p:cNvSpPr/>
           <p:nvPr/>
         </p:nvSpPr>
         <p:spPr>
           <a:xfrm>
             <a:off x="8321040" y="1417320"/>
-            <a:ext cx="0" cy="4206240"/>
+            <a:ext cx="0" cy="5074920"/>
           </a:xfrm>
           <a:prstGeom prst="line">
             <a:avLst/>

</xml_diff>